<commit_message>
SLight update to PPT
</commit_message>
<xml_diff>
--- a/VideoPlaybackSupportFiles/Video Playback FB Layout.pptx
+++ b/VideoPlaybackSupportFiles/Video Playback FB Layout.pptx
@@ -225,7 +225,7 @@
           <a:p>
             <a:fld id="{8F1A36FD-08A9-47F7-8F4B-E50EC98C36E7}" type="datetime1">
               <a:rPr lang="de-DE" smtClean="0"/>
-              <a:t>11.04.2022</a:t>
+              <a:t>05.05.2022</a:t>
             </a:fld>
             <a:endParaRPr lang="de-DE"/>
           </a:p>
@@ -407,7 +407,7 @@
           <a:p>
             <a:fld id="{0A2346E5-778D-4A7C-BA30-768202CBF653}" type="datetime1">
               <a:rPr lang="de-DE" smtClean="0"/>
-              <a:t>05.04.2022</a:t>
+              <a:t>05.05.2022</a:t>
             </a:fld>
             <a:endParaRPr lang="de-DE"/>
           </a:p>
@@ -12892,7 +12892,7 @@
           <a:p>
             <a:r>
               <a:rPr lang="en-US" dirty="0"/>
-              <a:t>Image Export Path</a:t>
+              <a:t>--</a:t>
             </a:r>
           </a:p>
         </p:txBody>

</xml_diff>